<commit_message>
Keep the earlier abstract and group the references as in the template
The abstract is the one from the first report with the new sentences
added, instead of a rewrite, and stays inside the template's 300 words.
References are grouped under the template's headings. The Word-file
builder no longer highlights unchanged sentences that sit between two new
ones, and the comments slide of the earlier deck names the response to
each comment.
</commit_message>
<xml_diff>
--- a/project_ppt_24bce2972_review2.pptx
+++ b/project_ppt_24bce2972_review2.pptx
@@ -6333,7 +6333,7 @@
                   <a:schemeClr val="tx1"/>
                 </a:solidFill>
               </a:rPr>
-              <a:t>Review 1 Comments</a:t>
+              <a:t>Review-01 Comments and Our Response</a:t>
             </a:r>
             <a:endParaRPr lang="en-US" sz="3200" dirty="0"/>
           </a:p>
@@ -6496,7 +6496,7 @@
                   <a:schemeClr val="accent1"/>
                 </a:solidFill>
               </a:rPr>
-              <a:t xml:space="preserve">1.  </a:t>
+              <a:t xml:space="preserve">Comment 1:  </a:t>
             </a:r>
             <a:r>
               <a:rPr sz="1900" b="1">
@@ -6537,7 +6537,7 @@
                   <a:schemeClr val="accent1"/>
                 </a:solidFill>
               </a:rPr>
-              <a:t xml:space="preserve">What was done: </a:t>
+              <a:t xml:space="preserve">Response / action: </a:t>
             </a:r>
             <a:r>
               <a:rPr sz="1450" b="0">
@@ -6662,7 +6662,7 @@
                   <a:schemeClr val="accent4"/>
                 </a:solidFill>
               </a:rPr>
-              <a:t xml:space="preserve">2.  </a:t>
+              <a:t xml:space="preserve">Comment 2:  </a:t>
             </a:r>
             <a:r>
               <a:rPr sz="1900" b="1">
@@ -6703,7 +6703,7 @@
                   <a:schemeClr val="accent4"/>
                 </a:solidFill>
               </a:rPr>
-              <a:t xml:space="preserve">What was done: </a:t>
+              <a:t xml:space="preserve">Response / action: </a:t>
             </a:r>
             <a:r>
               <a:rPr sz="1450" b="0">
@@ -6828,7 +6828,7 @@
                   <a:schemeClr val="accent2"/>
                 </a:solidFill>
               </a:rPr>
-              <a:t xml:space="preserve">3.  </a:t>
+              <a:t xml:space="preserve">Comment 3:  </a:t>
             </a:r>
             <a:r>
               <a:rPr sz="1900" b="1">
@@ -6869,7 +6869,7 @@
                   <a:schemeClr val="accent2"/>
                 </a:solidFill>
               </a:rPr>
-              <a:t xml:space="preserve">What was done: </a:t>
+              <a:t xml:space="preserve">Response / action: </a:t>
             </a:r>
             <a:r>
               <a:rPr sz="1450" b="0">
@@ -6877,7 +6877,7 @@
                   <a:schemeClr val="tx1"/>
                 </a:solidFill>
               </a:rPr>
-              <a:t xml:space="preserve">Added the class and data-flow diagrams, a comparison chart for each LLM against the rules, and result tables for all four configurations.</a:t>
+              <a:t xml:space="preserve">Added the class and data-flow diagrams, a comparison chart for each LLM against the rules, analysis charts for the Groq and Ollama runs in the report, and result tables for all four configurations.</a:t>
             </a:r>
           </a:p>
         </p:txBody>

</xml_diff>